<commit_message>
Fill the empty space on the cover and the closing slide
- Cover: a quiet agent orbit next to the title (ring, Plan / Act /
  Check / Improve nodes, "Your goal" at the centre, a task in flight).
  Each part is named for Morph, so on slide 2 it unfolds into the full
  loop diagram.
- Close: a big Georgia italic question mark inside the same orbit,
  echoing the cover.

Co-Authored-By: Claude Opus 5.5 <noreply@anthropic.com>
Claude-Session: https://claude.ai/code/session_01VjyMc1qqKyhiy3JSmQ35pJ
</commit_message>
<xml_diff>
--- a/pptx/AI-Agents.pptx
+++ b/pptx/AI-Agents.pptx
@@ -2320,7 +2320,383 @@
       </p:sp>
       <p:sp>
         <p:nvSpPr>
-          <p:cNvPr id="8" name="!!progress"/>
+          <p:cNvPr id="8" name="!!halo"/>
+          <p:cNvSpPr/>
+          <p:nvPr/>
+        </p:nvSpPr>
+        <p:spPr>
+          <a:xfrm>
+            <a:off x="8026400" y="1447800"/>
+            <a:ext cx="3454400" cy="3454400"/>
+          </a:xfrm>
+          <a:prstGeom prst="ellipse">
+            <a:avLst/>
+          </a:prstGeom>
+          <a:ln w="12700">
+            <a:solidFill>
+              <a:srgbClr val="2A2A2A"/>
+            </a:solidFill>
+            <a:prstDash val="dash"/>
+          </a:ln>
+        </p:spPr>
+      </p:sp>
+      <p:sp>
+        <p:nvSpPr>
+          <p:cNvPr id="9" name="!!ring"/>
+          <p:cNvSpPr/>
+          <p:nvPr/>
+        </p:nvSpPr>
+        <p:spPr>
+          <a:xfrm>
+            <a:off x="8356600" y="1778000"/>
+            <a:ext cx="2794000" cy="2794000"/>
+          </a:xfrm>
+          <a:prstGeom prst="ellipse">
+            <a:avLst/>
+          </a:prstGeom>
+          <a:ln w="15875">
+            <a:solidFill>
+              <a:srgbClr val="808080"/>
+            </a:solidFill>
+            <a:prstDash val="solid"/>
+          </a:ln>
+        </p:spPr>
+      </p:sp>
+      <p:sp>
+        <p:nvSpPr>
+          <p:cNvPr id="10" name="!!inner"/>
+          <p:cNvSpPr/>
+          <p:nvPr/>
+        </p:nvSpPr>
+        <p:spPr>
+          <a:xfrm>
+            <a:off x="9144000" y="2565400"/>
+            <a:ext cx="1219200" cy="1219200"/>
+          </a:xfrm>
+          <a:prstGeom prst="ellipse">
+            <a:avLst/>
+          </a:prstGeom>
+          <a:ln w="12700">
+            <a:solidFill>
+              <a:srgbClr val="2A2A2A"/>
+            </a:solidFill>
+            <a:prstDash val="solid"/>
+          </a:ln>
+        </p:spPr>
+      </p:sp>
+      <p:sp>
+        <p:nvSpPr>
+          <p:cNvPr id="11" name="!!node0"/>
+          <p:cNvSpPr/>
+          <p:nvPr/>
+        </p:nvSpPr>
+        <p:spPr>
+          <a:xfrm>
+            <a:off x="9671050" y="1695450"/>
+            <a:ext cx="165100" cy="165100"/>
+          </a:xfrm>
+          <a:prstGeom prst="ellipse">
+            <a:avLst/>
+          </a:prstGeom>
+          <a:solidFill>
+            <a:srgbClr val="FFFFFF"/>
+          </a:solidFill>
+          <a:ln/>
+        </p:spPr>
+      </p:sp>
+      <p:sp>
+        <p:nvSpPr>
+          <p:cNvPr id="12" name="!!nodeLabel0"/>
+          <p:cNvSpPr txBox="1"/>
+          <p:nvPr/>
+        </p:nvSpPr>
+        <p:spPr>
+          <a:xfrm>
+            <a:off x="9245600" y="1955800"/>
+            <a:ext cx="1016000" cy="215900"/>
+          </a:xfrm>
+          <a:prstGeom prst="rect">
+            <a:avLst/>
+          </a:prstGeom>
+          <a:noFill/>
+          <a:ln/>
+        </p:spPr>
+        <p:txBody>
+          <a:bodyPr wrap="square" lIns="0" tIns="0" rIns="0" bIns="0" rtlCol="0" anchor="ctr"/>
+          <a:lstStyle/>
+          <a:p>
+            <a:pPr algn="ctr" indent="0" marL="0">
+              <a:lnSpc>
+                <a:spcPct val="110000"/>
+              </a:lnSpc>
+              <a:buNone/>
+            </a:pPr>
+            <a:r>
+              <a:rPr lang="en-US" sz="1200" dirty="0">
+                <a:solidFill>
+                  <a:srgbClr val="8A8A8A"/>
+                </a:solidFill>
+                <a:latin typeface="Arial" pitchFamily="34" charset="0"/>
+                <a:ea typeface="Arial" pitchFamily="34" charset="-122"/>
+                <a:cs typeface="Arial" pitchFamily="34" charset="-120"/>
+              </a:rPr>
+              <a:t>Plan</a:t>
+            </a:r>
+            <a:endParaRPr lang="en-US" sz="1200" dirty="0"/>
+          </a:p>
+        </p:txBody>
+      </p:sp>
+      <p:sp>
+        <p:nvSpPr>
+          <p:cNvPr id="13" name="!!node1"/>
+          <p:cNvSpPr/>
+          <p:nvPr/>
+        </p:nvSpPr>
+        <p:spPr>
+          <a:xfrm>
+            <a:off x="11068050" y="3092450"/>
+            <a:ext cx="165100" cy="165100"/>
+          </a:xfrm>
+          <a:prstGeom prst="ellipse">
+            <a:avLst/>
+          </a:prstGeom>
+          <a:solidFill>
+            <a:srgbClr val="FFFFFF"/>
+          </a:solidFill>
+          <a:ln/>
+        </p:spPr>
+      </p:sp>
+      <p:sp>
+        <p:nvSpPr>
+          <p:cNvPr id="14" name="!!nodeLabel1"/>
+          <p:cNvSpPr txBox="1"/>
+          <p:nvPr/>
+        </p:nvSpPr>
+        <p:spPr>
+          <a:xfrm>
+            <a:off x="9931400" y="3067050"/>
+            <a:ext cx="1016000" cy="215900"/>
+          </a:xfrm>
+          <a:prstGeom prst="rect">
+            <a:avLst/>
+          </a:prstGeom>
+          <a:noFill/>
+          <a:ln/>
+        </p:spPr>
+        <p:txBody>
+          <a:bodyPr wrap="square" lIns="0" tIns="0" rIns="0" bIns="0" rtlCol="0" anchor="ctr"/>
+          <a:lstStyle/>
+          <a:p>
+            <a:pPr algn="r" indent="0" marL="0">
+              <a:lnSpc>
+                <a:spcPct val="110000"/>
+              </a:lnSpc>
+              <a:buNone/>
+            </a:pPr>
+            <a:r>
+              <a:rPr lang="en-US" sz="1200" dirty="0">
+                <a:solidFill>
+                  <a:srgbClr val="8A8A8A"/>
+                </a:solidFill>
+                <a:latin typeface="Arial" pitchFamily="34" charset="0"/>
+                <a:ea typeface="Arial" pitchFamily="34" charset="-122"/>
+                <a:cs typeface="Arial" pitchFamily="34" charset="-120"/>
+              </a:rPr>
+              <a:t>Act</a:t>
+            </a:r>
+            <a:endParaRPr lang="en-US" sz="1200" dirty="0"/>
+          </a:p>
+        </p:txBody>
+      </p:sp>
+      <p:sp>
+        <p:nvSpPr>
+          <p:cNvPr id="15" name="!!node2"/>
+          <p:cNvSpPr/>
+          <p:nvPr/>
+        </p:nvSpPr>
+        <p:spPr>
+          <a:xfrm>
+            <a:off x="9671050" y="4489450"/>
+            <a:ext cx="165100" cy="165100"/>
+          </a:xfrm>
+          <a:prstGeom prst="ellipse">
+            <a:avLst/>
+          </a:prstGeom>
+          <a:solidFill>
+            <a:srgbClr val="FFFFFF"/>
+          </a:solidFill>
+          <a:ln/>
+        </p:spPr>
+      </p:sp>
+      <p:sp>
+        <p:nvSpPr>
+          <p:cNvPr id="16" name="!!nodeLabel2"/>
+          <p:cNvSpPr txBox="1"/>
+          <p:nvPr/>
+        </p:nvSpPr>
+        <p:spPr>
+          <a:xfrm>
+            <a:off x="9245600" y="4178300"/>
+            <a:ext cx="1016000" cy="215900"/>
+          </a:xfrm>
+          <a:prstGeom prst="rect">
+            <a:avLst/>
+          </a:prstGeom>
+          <a:noFill/>
+          <a:ln/>
+        </p:spPr>
+        <p:txBody>
+          <a:bodyPr wrap="square" lIns="0" tIns="0" rIns="0" bIns="0" rtlCol="0" anchor="ctr"/>
+          <a:lstStyle/>
+          <a:p>
+            <a:pPr algn="ctr" indent="0" marL="0">
+              <a:lnSpc>
+                <a:spcPct val="110000"/>
+              </a:lnSpc>
+              <a:buNone/>
+            </a:pPr>
+            <a:r>
+              <a:rPr lang="en-US" sz="1200" dirty="0">
+                <a:solidFill>
+                  <a:srgbClr val="8A8A8A"/>
+                </a:solidFill>
+                <a:latin typeface="Arial" pitchFamily="34" charset="0"/>
+                <a:ea typeface="Arial" pitchFamily="34" charset="-122"/>
+                <a:cs typeface="Arial" pitchFamily="34" charset="-120"/>
+              </a:rPr>
+              <a:t>Check</a:t>
+            </a:r>
+            <a:endParaRPr lang="en-US" sz="1200" dirty="0"/>
+          </a:p>
+        </p:txBody>
+      </p:sp>
+      <p:sp>
+        <p:nvSpPr>
+          <p:cNvPr id="17" name="!!node3"/>
+          <p:cNvSpPr/>
+          <p:nvPr/>
+        </p:nvSpPr>
+        <p:spPr>
+          <a:xfrm>
+            <a:off x="8274050" y="3092450"/>
+            <a:ext cx="165100" cy="165100"/>
+          </a:xfrm>
+          <a:prstGeom prst="ellipse">
+            <a:avLst/>
+          </a:prstGeom>
+          <a:solidFill>
+            <a:srgbClr val="FFFFFF"/>
+          </a:solidFill>
+          <a:ln/>
+        </p:spPr>
+      </p:sp>
+      <p:sp>
+        <p:nvSpPr>
+          <p:cNvPr id="18" name="!!nodeLabel3"/>
+          <p:cNvSpPr txBox="1"/>
+          <p:nvPr/>
+        </p:nvSpPr>
+        <p:spPr>
+          <a:xfrm>
+            <a:off x="8559800" y="3067050"/>
+            <a:ext cx="1016000" cy="215900"/>
+          </a:xfrm>
+          <a:prstGeom prst="rect">
+            <a:avLst/>
+          </a:prstGeom>
+          <a:noFill/>
+          <a:ln/>
+        </p:spPr>
+        <p:txBody>
+          <a:bodyPr wrap="square" lIns="0" tIns="0" rIns="0" bIns="0" rtlCol="0" anchor="ctr"/>
+          <a:lstStyle/>
+          <a:p>
+            <a:pPr algn="l" indent="0" marL="0">
+              <a:lnSpc>
+                <a:spcPct val="110000"/>
+              </a:lnSpc>
+              <a:buNone/>
+            </a:pPr>
+            <a:r>
+              <a:rPr lang="en-US" sz="1200" dirty="0">
+                <a:solidFill>
+                  <a:srgbClr val="8A8A8A"/>
+                </a:solidFill>
+                <a:latin typeface="Arial" pitchFamily="34" charset="0"/>
+                <a:ea typeface="Arial" pitchFamily="34" charset="-122"/>
+                <a:cs typeface="Arial" pitchFamily="34" charset="-120"/>
+              </a:rPr>
+              <a:t>Improve</a:t>
+            </a:r>
+            <a:endParaRPr lang="en-US" sz="1200" dirty="0"/>
+          </a:p>
+        </p:txBody>
+      </p:sp>
+      <p:sp>
+        <p:nvSpPr>
+          <p:cNvPr id="19" name="!!orbit"/>
+          <p:cNvSpPr/>
+          <p:nvPr/>
+        </p:nvSpPr>
+        <p:spPr>
+          <a:xfrm>
+            <a:off x="10690628" y="2136372"/>
+            <a:ext cx="101600" cy="101600"/>
+          </a:xfrm>
+          <a:prstGeom prst="ellipse">
+            <a:avLst/>
+          </a:prstGeom>
+          <a:solidFill>
+            <a:srgbClr val="FFFFFF"/>
+          </a:solidFill>
+          <a:ln/>
+        </p:spPr>
+      </p:sp>
+      <p:sp>
+        <p:nvSpPr>
+          <p:cNvPr id="20" name="!!goal"/>
+          <p:cNvSpPr txBox="1"/>
+          <p:nvPr/>
+        </p:nvSpPr>
+        <p:spPr>
+          <a:xfrm>
+            <a:off x="9144000" y="2984500"/>
+            <a:ext cx="1219200" cy="381000"/>
+          </a:xfrm>
+          <a:prstGeom prst="rect">
+            <a:avLst/>
+          </a:prstGeom>
+          <a:noFill/>
+          <a:ln/>
+        </p:spPr>
+        <p:txBody>
+          <a:bodyPr wrap="square" lIns="0" tIns="0" rIns="0" bIns="0" rtlCol="0" anchor="ctr"/>
+          <a:lstStyle/>
+          <a:p>
+            <a:pPr algn="ctr" indent="0" marL="0">
+              <a:lnSpc>
+                <a:spcPct val="110000"/>
+              </a:lnSpc>
+              <a:buNone/>
+            </a:pPr>
+            <a:r>
+              <a:rPr lang="en-US" sz="1500" i="1" dirty="0">
+                <a:solidFill>
+                  <a:srgbClr val="FFFFFF"/>
+                </a:solidFill>
+                <a:latin typeface="Georgia" pitchFamily="34" charset="0"/>
+                <a:ea typeface="Georgia" pitchFamily="34" charset="-122"/>
+                <a:cs typeface="Georgia" pitchFamily="34" charset="-120"/>
+              </a:rPr>
+              <a:t>Your goal</a:t>
+            </a:r>
+            <a:endParaRPr lang="en-US" sz="1500" dirty="0"/>
+          </a:p>
+        </p:txBody>
+      </p:sp>
+      <p:sp>
+        <p:nvSpPr>
+          <p:cNvPr id="21" name="!!progress"/>
           <p:cNvSpPr/>
           <p:nvPr/>
         </p:nvSpPr>
@@ -6026,7 +6402,113 @@
       </p:sp>
       <p:sp>
         <p:nvSpPr>
-          <p:cNvPr id="11" name="!!progress"/>
+          <p:cNvPr id="11" name="!!halo"/>
+          <p:cNvSpPr/>
+          <p:nvPr/>
+        </p:nvSpPr>
+        <p:spPr>
+          <a:xfrm>
+            <a:off x="7607300" y="1257300"/>
+            <a:ext cx="3835400" cy="3835400"/>
+          </a:xfrm>
+          <a:prstGeom prst="ellipse">
+            <a:avLst/>
+          </a:prstGeom>
+          <a:ln w="12700">
+            <a:solidFill>
+              <a:srgbClr val="2A2A2A"/>
+            </a:solidFill>
+            <a:prstDash val="dash"/>
+          </a:ln>
+        </p:spPr>
+      </p:sp>
+      <p:sp>
+        <p:nvSpPr>
+          <p:cNvPr id="12" name="!!ring"/>
+          <p:cNvSpPr/>
+          <p:nvPr/>
+        </p:nvSpPr>
+        <p:spPr>
+          <a:xfrm>
+            <a:off x="7937500" y="1587500"/>
+            <a:ext cx="3175000" cy="3175000"/>
+          </a:xfrm>
+          <a:prstGeom prst="ellipse">
+            <a:avLst/>
+          </a:prstGeom>
+          <a:ln w="15875">
+            <a:solidFill>
+              <a:srgbClr val="2A2A2A"/>
+            </a:solidFill>
+            <a:prstDash val="solid"/>
+          </a:ln>
+        </p:spPr>
+      </p:sp>
+      <p:sp>
+        <p:nvSpPr>
+          <p:cNvPr id="13" name="!!orbit"/>
+          <p:cNvSpPr/>
+          <p:nvPr/>
+        </p:nvSpPr>
+        <p:spPr>
+          <a:xfrm>
+            <a:off x="10596732" y="2001668"/>
+            <a:ext cx="101600" cy="101600"/>
+          </a:xfrm>
+          <a:prstGeom prst="ellipse">
+            <a:avLst/>
+          </a:prstGeom>
+          <a:solidFill>
+            <a:srgbClr val="FFFFFF"/>
+          </a:solidFill>
+          <a:ln/>
+        </p:spPr>
+      </p:sp>
+      <p:sp>
+        <p:nvSpPr>
+          <p:cNvPr id="14" name="!!question"/>
+          <p:cNvSpPr txBox="1"/>
+          <p:nvPr/>
+        </p:nvSpPr>
+        <p:spPr>
+          <a:xfrm>
+            <a:off x="7683500" y="1587500"/>
+            <a:ext cx="3175000" cy="3175000"/>
+          </a:xfrm>
+          <a:prstGeom prst="rect">
+            <a:avLst/>
+          </a:prstGeom>
+          <a:noFill/>
+          <a:ln/>
+        </p:spPr>
+        <p:txBody>
+          <a:bodyPr wrap="square" lIns="0" tIns="0" rIns="0" bIns="0" rtlCol="0" anchor="ctr"/>
+          <a:lstStyle/>
+          <a:p>
+            <a:pPr algn="ctr" indent="0" marL="0">
+              <a:lnSpc>
+                <a:spcPct val="100000"/>
+              </a:lnSpc>
+              <a:buNone/>
+            </a:pPr>
+            <a:r>
+              <a:rPr lang="en-US" sz="28000" i="1" dirty="0">
+                <a:solidFill>
+                  <a:srgbClr val="FFFFFF"/>
+                </a:solidFill>
+                <a:latin typeface="Georgia" pitchFamily="34" charset="0"/>
+                <a:ea typeface="Georgia" pitchFamily="34" charset="-122"/>
+                <a:cs typeface="Georgia" pitchFamily="34" charset="-120"/>
+              </a:rPr>
+              <a:t>?</a:t>
+            </a:r>
+            <a:endParaRPr lang="en-US" sz="28000" dirty="0"/>
+          </a:p>
+        </p:txBody>
+      </p:sp>
+      <p:sp>
+        <p:nvSpPr>
+          <p:cNvPr id="15" name="!!progress"/>
           <p:cNvSpPr/>
           <p:nvPr/>
         </p:nvSpPr>
@@ -6396,7 +6878,7 @@
       </p:sp>
       <p:sp>
         <p:nvSpPr>
-          <p:cNvPr id="9" name="Shape 7"/>
+          <p:cNvPr id="9" name="!!ring"/>
           <p:cNvSpPr/>
           <p:nvPr/>
         </p:nvSpPr>
@@ -6418,7 +6900,7 @@
       </p:sp>
       <p:sp>
         <p:nvSpPr>
-          <p:cNvPr id="10" name="Shape 8"/>
+          <p:cNvPr id="10" name="!!node0"/>
           <p:cNvSpPr/>
           <p:nvPr/>
         </p:nvSpPr>
@@ -6443,7 +6925,7 @@
       </p:sp>
       <p:sp>
         <p:nvSpPr>
-          <p:cNvPr id="11" name="Text 9"/>
+          <p:cNvPr id="11" name="!!nodeLabel0"/>
           <p:cNvSpPr txBox="1"/>
           <p:nvPr/>
         </p:nvSpPr>
@@ -6485,7 +6967,7 @@
       </p:sp>
       <p:sp>
         <p:nvSpPr>
-          <p:cNvPr id="12" name="Shape 10"/>
+          <p:cNvPr id="12" name="!!node1"/>
           <p:cNvSpPr/>
           <p:nvPr/>
         </p:nvSpPr>
@@ -6510,7 +6992,7 @@
       </p:sp>
       <p:sp>
         <p:nvSpPr>
-          <p:cNvPr id="13" name="Text 11"/>
+          <p:cNvPr id="13" name="!!nodeLabel1"/>
           <p:cNvSpPr txBox="1"/>
           <p:nvPr/>
         </p:nvSpPr>
@@ -6552,7 +7034,7 @@
       </p:sp>
       <p:sp>
         <p:nvSpPr>
-          <p:cNvPr id="14" name="Shape 12"/>
+          <p:cNvPr id="14" name="!!node2"/>
           <p:cNvSpPr/>
           <p:nvPr/>
         </p:nvSpPr>
@@ -6577,7 +7059,7 @@
       </p:sp>
       <p:sp>
         <p:nvSpPr>
-          <p:cNvPr id="15" name="Text 13"/>
+          <p:cNvPr id="15" name="!!nodeLabel2"/>
           <p:cNvSpPr txBox="1"/>
           <p:nvPr/>
         </p:nvSpPr>
@@ -6619,7 +7101,7 @@
       </p:sp>
       <p:sp>
         <p:nvSpPr>
-          <p:cNvPr id="16" name="Shape 14"/>
+          <p:cNvPr id="16" name="!!node3"/>
           <p:cNvSpPr/>
           <p:nvPr/>
         </p:nvSpPr>
@@ -6644,7 +7126,7 @@
       </p:sp>
       <p:sp>
         <p:nvSpPr>
-          <p:cNvPr id="17" name="Text 15"/>
+          <p:cNvPr id="17" name="!!nodeLabel3"/>
           <p:cNvSpPr txBox="1"/>
           <p:nvPr/>
         </p:nvSpPr>
@@ -6686,7 +7168,27 @@
       </p:sp>
       <p:sp>
         <p:nvSpPr>
-          <p:cNvPr id="18" name="Text 16"/>
+          <p:cNvPr id="18" name="!!orbit"/>
+          <p:cNvSpPr/>
+          <p:nvPr/>
+        </p:nvSpPr>
+        <p:spPr>
+          <a:xfrm>
+            <a:off x="10145882" y="4621382"/>
+            <a:ext cx="114300" cy="114300"/>
+          </a:xfrm>
+          <a:prstGeom prst="ellipse">
+            <a:avLst/>
+          </a:prstGeom>
+          <a:solidFill>
+            <a:srgbClr val="0A0A0A"/>
+          </a:solidFill>
+          <a:ln/>
+        </p:spPr>
+      </p:sp>
+      <p:sp>
+        <p:nvSpPr>
+          <p:cNvPr id="19" name="!!goal"/>
           <p:cNvSpPr txBox="1"/>
           <p:nvPr/>
         </p:nvSpPr>
@@ -6728,7 +7230,7 @@
       </p:sp>
       <p:sp>
         <p:nvSpPr>
-          <p:cNvPr id="19" name="!!section"/>
+          <p:cNvPr id="20" name="!!section"/>
           <p:cNvSpPr txBox="1"/>
           <p:nvPr/>
         </p:nvSpPr>
@@ -6770,7 +7272,7 @@
       </p:sp>
       <p:sp>
         <p:nvSpPr>
-          <p:cNvPr id="20" name="!!count"/>
+          <p:cNvPr id="21" name="!!count"/>
           <p:cNvSpPr txBox="1"/>
           <p:nvPr/>
         </p:nvSpPr>
@@ -6829,7 +7331,7 @@
       </p:sp>
       <p:sp>
         <p:nvSpPr>
-          <p:cNvPr id="21" name="!!progress"/>
+          <p:cNvPr id="22" name="!!progress"/>
           <p:cNvSpPr/>
           <p:nvPr/>
         </p:nvSpPr>

</xml_diff>

<commit_message>
Replace the cover and closing orbits with original halftone art
The cover orbit repeated the slide 2 loop. Now:
- Cover: a halftone dot sphere, lit from the top left, with eight bright
  nodes wired together on its surface and a tilted orbit line.
- Close: a large question mark built from the same dots, with particles
  drifting in around it.

Both are generated by pptx/art/make_art.py (Pillow, EB Garamond italic).

Co-Authored-By: Claude Opus 5.5 <noreply@anthropic.com>
Claude-Session: https://claude.ai/code/session_01VjyMc1qqKyhiy3JSmQ35pJ
</commit_message>
<xml_diff>
--- a/pptx/AI-Agents.pptx
+++ b/pptx/AI-Agents.pptx
@@ -2318,385 +2318,33 @@
           </a:p>
         </p:txBody>
       </p:sp>
-      <p:sp>
-        <p:nvSpPr>
-          <p:cNvPr id="8" name="!!halo"/>
-          <p:cNvSpPr/>
-          <p:nvPr/>
-        </p:nvSpPr>
-        <p:spPr>
-          <a:xfrm>
-            <a:off x="8026400" y="1447800"/>
-            <a:ext cx="3454400" cy="3454400"/>
-          </a:xfrm>
-          <a:prstGeom prst="ellipse">
-            <a:avLst/>
-          </a:prstGeom>
-          <a:ln w="12700">
-            <a:solidFill>
-              <a:srgbClr val="2A2A2A"/>
-            </a:solidFill>
-            <a:prstDash val="dash"/>
-          </a:ln>
-        </p:spPr>
-      </p:sp>
-      <p:sp>
-        <p:nvSpPr>
-          <p:cNvPr id="9" name="!!ring"/>
-          <p:cNvSpPr/>
-          <p:nvPr/>
-        </p:nvSpPr>
-        <p:spPr>
-          <a:xfrm>
-            <a:off x="8356600" y="1778000"/>
-            <a:ext cx="2794000" cy="2794000"/>
-          </a:xfrm>
-          <a:prstGeom prst="ellipse">
-            <a:avLst/>
-          </a:prstGeom>
-          <a:ln w="15875">
-            <a:solidFill>
-              <a:srgbClr val="808080"/>
-            </a:solidFill>
-            <a:prstDash val="solid"/>
-          </a:ln>
-        </p:spPr>
-      </p:sp>
-      <p:sp>
-        <p:nvSpPr>
-          <p:cNvPr id="10" name="!!inner"/>
-          <p:cNvSpPr/>
-          <p:nvPr/>
-        </p:nvSpPr>
-        <p:spPr>
-          <a:xfrm>
-            <a:off x="9144000" y="2565400"/>
-            <a:ext cx="1219200" cy="1219200"/>
-          </a:xfrm>
-          <a:prstGeom prst="ellipse">
-            <a:avLst/>
-          </a:prstGeom>
-          <a:ln w="12700">
-            <a:solidFill>
-              <a:srgbClr val="2A2A2A"/>
-            </a:solidFill>
-            <a:prstDash val="solid"/>
-          </a:ln>
-        </p:spPr>
-      </p:sp>
-      <p:sp>
-        <p:nvSpPr>
-          <p:cNvPr id="11" name="!!node0"/>
-          <p:cNvSpPr/>
-          <p:nvPr/>
-        </p:nvSpPr>
-        <p:spPr>
-          <a:xfrm>
-            <a:off x="9671050" y="1695450"/>
-            <a:ext cx="165100" cy="165100"/>
-          </a:xfrm>
-          <a:prstGeom prst="ellipse">
-            <a:avLst/>
-          </a:prstGeom>
-          <a:solidFill>
-            <a:srgbClr val="FFFFFF"/>
-          </a:solidFill>
-          <a:ln/>
-        </p:spPr>
-      </p:sp>
-      <p:sp>
-        <p:nvSpPr>
-          <p:cNvPr id="12" name="!!nodeLabel0"/>
-          <p:cNvSpPr txBox="1"/>
-          <p:nvPr/>
-        </p:nvSpPr>
-        <p:spPr>
-          <a:xfrm>
-            <a:off x="9245600" y="1955800"/>
-            <a:ext cx="1016000" cy="215900"/>
-          </a:xfrm>
-          <a:prstGeom prst="rect">
-            <a:avLst/>
-          </a:prstGeom>
-          <a:noFill/>
-          <a:ln/>
-        </p:spPr>
-        <p:txBody>
-          <a:bodyPr wrap="square" lIns="0" tIns="0" rIns="0" bIns="0" rtlCol="0" anchor="ctr"/>
-          <a:lstStyle/>
-          <a:p>
-            <a:pPr algn="ctr" indent="0" marL="0">
-              <a:lnSpc>
-                <a:spcPct val="110000"/>
-              </a:lnSpc>
-              <a:buNone/>
-            </a:pPr>
-            <a:r>
-              <a:rPr lang="en-US" sz="1200" dirty="0">
-                <a:solidFill>
-                  <a:srgbClr val="8A8A8A"/>
-                </a:solidFill>
-                <a:latin typeface="Arial" pitchFamily="34" charset="0"/>
-                <a:ea typeface="Arial" pitchFamily="34" charset="-122"/>
-                <a:cs typeface="Arial" pitchFamily="34" charset="-120"/>
-              </a:rPr>
-              <a:t>Plan</a:t>
-            </a:r>
-            <a:endParaRPr lang="en-US" sz="1200" dirty="0"/>
-          </a:p>
-        </p:txBody>
-      </p:sp>
-      <p:sp>
-        <p:nvSpPr>
-          <p:cNvPr id="13" name="!!node1"/>
-          <p:cNvSpPr/>
-          <p:nvPr/>
-        </p:nvSpPr>
-        <p:spPr>
-          <a:xfrm>
-            <a:off x="11068050" y="3092450"/>
-            <a:ext cx="165100" cy="165100"/>
-          </a:xfrm>
-          <a:prstGeom prst="ellipse">
-            <a:avLst/>
-          </a:prstGeom>
-          <a:solidFill>
-            <a:srgbClr val="FFFFFF"/>
-          </a:solidFill>
-          <a:ln/>
-        </p:spPr>
-      </p:sp>
-      <p:sp>
-        <p:nvSpPr>
-          <p:cNvPr id="14" name="!!nodeLabel1"/>
-          <p:cNvSpPr txBox="1"/>
-          <p:nvPr/>
-        </p:nvSpPr>
-        <p:spPr>
-          <a:xfrm>
-            <a:off x="9931400" y="3067050"/>
-            <a:ext cx="1016000" cy="215900"/>
-          </a:xfrm>
-          <a:prstGeom prst="rect">
-            <a:avLst/>
-          </a:prstGeom>
-          <a:noFill/>
-          <a:ln/>
-        </p:spPr>
-        <p:txBody>
-          <a:bodyPr wrap="square" lIns="0" tIns="0" rIns="0" bIns="0" rtlCol="0" anchor="ctr"/>
-          <a:lstStyle/>
-          <a:p>
-            <a:pPr algn="r" indent="0" marL="0">
-              <a:lnSpc>
-                <a:spcPct val="110000"/>
-              </a:lnSpc>
-              <a:buNone/>
-            </a:pPr>
-            <a:r>
-              <a:rPr lang="en-US" sz="1200" dirty="0">
-                <a:solidFill>
-                  <a:srgbClr val="8A8A8A"/>
-                </a:solidFill>
-                <a:latin typeface="Arial" pitchFamily="34" charset="0"/>
-                <a:ea typeface="Arial" pitchFamily="34" charset="-122"/>
-                <a:cs typeface="Arial" pitchFamily="34" charset="-120"/>
-              </a:rPr>
-              <a:t>Act</a:t>
-            </a:r>
-            <a:endParaRPr lang="en-US" sz="1200" dirty="0"/>
-          </a:p>
-        </p:txBody>
-      </p:sp>
-      <p:sp>
-        <p:nvSpPr>
-          <p:cNvPr id="15" name="!!node2"/>
-          <p:cNvSpPr/>
-          <p:nvPr/>
-        </p:nvSpPr>
-        <p:spPr>
-          <a:xfrm>
-            <a:off x="9671050" y="4489450"/>
-            <a:ext cx="165100" cy="165100"/>
-          </a:xfrm>
-          <a:prstGeom prst="ellipse">
-            <a:avLst/>
-          </a:prstGeom>
-          <a:solidFill>
-            <a:srgbClr val="FFFFFF"/>
-          </a:solidFill>
-          <a:ln/>
-        </p:spPr>
-      </p:sp>
-      <p:sp>
-        <p:nvSpPr>
-          <p:cNvPr id="16" name="!!nodeLabel2"/>
-          <p:cNvSpPr txBox="1"/>
-          <p:nvPr/>
-        </p:nvSpPr>
-        <p:spPr>
-          <a:xfrm>
-            <a:off x="9245600" y="4178300"/>
-            <a:ext cx="1016000" cy="215900"/>
-          </a:xfrm>
-          <a:prstGeom prst="rect">
-            <a:avLst/>
-          </a:prstGeom>
-          <a:noFill/>
-          <a:ln/>
-        </p:spPr>
-        <p:txBody>
-          <a:bodyPr wrap="square" lIns="0" tIns="0" rIns="0" bIns="0" rtlCol="0" anchor="ctr"/>
-          <a:lstStyle/>
-          <a:p>
-            <a:pPr algn="ctr" indent="0" marL="0">
-              <a:lnSpc>
-                <a:spcPct val="110000"/>
-              </a:lnSpc>
-              <a:buNone/>
-            </a:pPr>
-            <a:r>
-              <a:rPr lang="en-US" sz="1200" dirty="0">
-                <a:solidFill>
-                  <a:srgbClr val="8A8A8A"/>
-                </a:solidFill>
-                <a:latin typeface="Arial" pitchFamily="34" charset="0"/>
-                <a:ea typeface="Arial" pitchFamily="34" charset="-122"/>
-                <a:cs typeface="Arial" pitchFamily="34" charset="-120"/>
-              </a:rPr>
-              <a:t>Check</a:t>
-            </a:r>
-            <a:endParaRPr lang="en-US" sz="1200" dirty="0"/>
-          </a:p>
-        </p:txBody>
-      </p:sp>
-      <p:sp>
-        <p:nvSpPr>
-          <p:cNvPr id="17" name="!!node3"/>
-          <p:cNvSpPr/>
-          <p:nvPr/>
-        </p:nvSpPr>
-        <p:spPr>
-          <a:xfrm>
-            <a:off x="8274050" y="3092450"/>
-            <a:ext cx="165100" cy="165100"/>
-          </a:xfrm>
-          <a:prstGeom prst="ellipse">
-            <a:avLst/>
-          </a:prstGeom>
-          <a:solidFill>
-            <a:srgbClr val="FFFFFF"/>
-          </a:solidFill>
-          <a:ln/>
-        </p:spPr>
-      </p:sp>
-      <p:sp>
-        <p:nvSpPr>
-          <p:cNvPr id="18" name="!!nodeLabel3"/>
-          <p:cNvSpPr txBox="1"/>
-          <p:nvPr/>
-        </p:nvSpPr>
-        <p:spPr>
-          <a:xfrm>
-            <a:off x="8559800" y="3067050"/>
-            <a:ext cx="1016000" cy="215900"/>
-          </a:xfrm>
-          <a:prstGeom prst="rect">
-            <a:avLst/>
-          </a:prstGeom>
-          <a:noFill/>
-          <a:ln/>
-        </p:spPr>
-        <p:txBody>
-          <a:bodyPr wrap="square" lIns="0" tIns="0" rIns="0" bIns="0" rtlCol="0" anchor="ctr"/>
-          <a:lstStyle/>
-          <a:p>
-            <a:pPr algn="l" indent="0" marL="0">
-              <a:lnSpc>
-                <a:spcPct val="110000"/>
-              </a:lnSpc>
-              <a:buNone/>
-            </a:pPr>
-            <a:r>
-              <a:rPr lang="en-US" sz="1200" dirty="0">
-                <a:solidFill>
-                  <a:srgbClr val="8A8A8A"/>
-                </a:solidFill>
-                <a:latin typeface="Arial" pitchFamily="34" charset="0"/>
-                <a:ea typeface="Arial" pitchFamily="34" charset="-122"/>
-                <a:cs typeface="Arial" pitchFamily="34" charset="-120"/>
-              </a:rPr>
-              <a:t>Improve</a:t>
-            </a:r>
-            <a:endParaRPr lang="en-US" sz="1200" dirty="0"/>
-          </a:p>
-        </p:txBody>
-      </p:sp>
-      <p:sp>
-        <p:nvSpPr>
-          <p:cNvPr id="19" name="!!orbit"/>
-          <p:cNvSpPr/>
-          <p:nvPr/>
-        </p:nvSpPr>
-        <p:spPr>
-          <a:xfrm>
-            <a:off x="10690628" y="2136372"/>
-            <a:ext cx="101600" cy="101600"/>
-          </a:xfrm>
-          <a:prstGeom prst="ellipse">
-            <a:avLst/>
-          </a:prstGeom>
-          <a:solidFill>
-            <a:srgbClr val="FFFFFF"/>
-          </a:solidFill>
-          <a:ln/>
-        </p:spPr>
-      </p:sp>
-      <p:sp>
-        <p:nvSpPr>
-          <p:cNvPr id="20" name="!!goal"/>
-          <p:cNvSpPr txBox="1"/>
-          <p:nvPr/>
-        </p:nvSpPr>
-        <p:spPr>
-          <a:xfrm>
-            <a:off x="9144000" y="2984500"/>
-            <a:ext cx="1219200" cy="381000"/>
-          </a:xfrm>
-          <a:prstGeom prst="rect">
-            <a:avLst/>
-          </a:prstGeom>
-          <a:noFill/>
-          <a:ln/>
-        </p:spPr>
-        <p:txBody>
-          <a:bodyPr wrap="square" lIns="0" tIns="0" rIns="0" bIns="0" rtlCol="0" anchor="ctr"/>
-          <a:lstStyle/>
-          <a:p>
-            <a:pPr algn="ctr" indent="0" marL="0">
-              <a:lnSpc>
-                <a:spcPct val="110000"/>
-              </a:lnSpc>
-              <a:buNone/>
-            </a:pPr>
-            <a:r>
-              <a:rPr lang="en-US" sz="1500" i="1" dirty="0">
-                <a:solidFill>
-                  <a:srgbClr val="FFFFFF"/>
-                </a:solidFill>
-                <a:latin typeface="Georgia" pitchFamily="34" charset="0"/>
-                <a:ea typeface="Georgia" pitchFamily="34" charset="-122"/>
-                <a:cs typeface="Georgia" pitchFamily="34" charset="-120"/>
-              </a:rPr>
-              <a:t>Your goal</a:t>
-            </a:r>
-            <a:endParaRPr lang="en-US" sz="1500" dirty="0"/>
-          </a:p>
-        </p:txBody>
-      </p:sp>
-      <p:sp>
-        <p:nvSpPr>
-          <p:cNvPr id="21" name="!!progress"/>
+      <p:pic>
+        <p:nvPicPr>
+          <p:cNvPr id="8" name="cover-art" descr="/home/user/presentation/pptx/art/sphere.png">    </p:cNvPr>
+          <p:cNvPicPr>
+            <a:picLocks noChangeAspect="1"/>
+          </p:cNvPicPr>
+          <p:nvPr/>
+        </p:nvPicPr>
+        <p:blipFill>
+          <a:blip r:embed="rId1"/>
+          <a:stretch>
+            <a:fillRect/>
+          </a:stretch>
+        </p:blipFill>
+        <p:spPr>
+          <a:xfrm>
+            <a:off x="7213600" y="825500"/>
+            <a:ext cx="4191000" cy="4191000"/>
+          </a:xfrm>
+          <a:prstGeom prst="rect">
+            <a:avLst/>
+          </a:prstGeom>
+        </p:spPr>
+      </p:pic>
+      <p:sp>
+        <p:nvSpPr>
+          <p:cNvPr id="9" name="!!progress"/>
           <p:cNvSpPr/>
           <p:nvPr/>
         </p:nvSpPr>
@@ -6400,115 +6048,33 @@
           </a:p>
         </p:txBody>
       </p:sp>
-      <p:sp>
-        <p:nvSpPr>
-          <p:cNvPr id="11" name="!!halo"/>
-          <p:cNvSpPr/>
-          <p:nvPr/>
-        </p:nvSpPr>
-        <p:spPr>
-          <a:xfrm>
-            <a:off x="7607300" y="1257300"/>
-            <a:ext cx="3835400" cy="3835400"/>
-          </a:xfrm>
-          <a:prstGeom prst="ellipse">
-            <a:avLst/>
-          </a:prstGeom>
-          <a:ln w="12700">
-            <a:solidFill>
-              <a:srgbClr val="2A2A2A"/>
-            </a:solidFill>
-            <a:prstDash val="dash"/>
-          </a:ln>
-        </p:spPr>
-      </p:sp>
-      <p:sp>
-        <p:nvSpPr>
-          <p:cNvPr id="12" name="!!ring"/>
-          <p:cNvSpPr/>
-          <p:nvPr/>
-        </p:nvSpPr>
-        <p:spPr>
-          <a:xfrm>
-            <a:off x="7937500" y="1587500"/>
-            <a:ext cx="3175000" cy="3175000"/>
-          </a:xfrm>
-          <a:prstGeom prst="ellipse">
-            <a:avLst/>
-          </a:prstGeom>
-          <a:ln w="15875">
-            <a:solidFill>
-              <a:srgbClr val="2A2A2A"/>
-            </a:solidFill>
-            <a:prstDash val="solid"/>
-          </a:ln>
-        </p:spPr>
-      </p:sp>
-      <p:sp>
-        <p:nvSpPr>
-          <p:cNvPr id="13" name="!!orbit"/>
-          <p:cNvSpPr/>
-          <p:nvPr/>
-        </p:nvSpPr>
-        <p:spPr>
-          <a:xfrm>
-            <a:off x="10596732" y="2001668"/>
-            <a:ext cx="101600" cy="101600"/>
-          </a:xfrm>
-          <a:prstGeom prst="ellipse">
-            <a:avLst/>
-          </a:prstGeom>
-          <a:solidFill>
-            <a:srgbClr val="FFFFFF"/>
-          </a:solidFill>
-          <a:ln/>
-        </p:spPr>
-      </p:sp>
-      <p:sp>
-        <p:nvSpPr>
-          <p:cNvPr id="14" name="!!question"/>
-          <p:cNvSpPr txBox="1"/>
-          <p:nvPr/>
-        </p:nvSpPr>
-        <p:spPr>
-          <a:xfrm>
-            <a:off x="7683500" y="1587500"/>
-            <a:ext cx="3175000" cy="3175000"/>
-          </a:xfrm>
-          <a:prstGeom prst="rect">
-            <a:avLst/>
-          </a:prstGeom>
-          <a:noFill/>
-          <a:ln/>
-        </p:spPr>
-        <p:txBody>
-          <a:bodyPr wrap="square" lIns="0" tIns="0" rIns="0" bIns="0" rtlCol="0" anchor="ctr"/>
-          <a:lstStyle/>
-          <a:p>
-            <a:pPr algn="ctr" indent="0" marL="0">
-              <a:lnSpc>
-                <a:spcPct val="100000"/>
-              </a:lnSpc>
-              <a:buNone/>
-            </a:pPr>
-            <a:r>
-              <a:rPr lang="en-US" sz="28000" i="1" dirty="0">
-                <a:solidFill>
-                  <a:srgbClr val="FFFFFF"/>
-                </a:solidFill>
-                <a:latin typeface="Georgia" pitchFamily="34" charset="0"/>
-                <a:ea typeface="Georgia" pitchFamily="34" charset="-122"/>
-                <a:cs typeface="Georgia" pitchFamily="34" charset="-120"/>
-              </a:rPr>
-              <a:t>?</a:t>
-            </a:r>
-            <a:endParaRPr lang="en-US" sz="28000" dirty="0"/>
-          </a:p>
-        </p:txBody>
-      </p:sp>
-      <p:sp>
-        <p:nvSpPr>
-          <p:cNvPr id="15" name="!!progress"/>
+      <p:pic>
+        <p:nvPicPr>
+          <p:cNvPr id="11" name="close-art" descr="/home/user/presentation/pptx/art/question.png">    </p:cNvPr>
+          <p:cNvPicPr>
+            <a:picLocks noChangeAspect="1"/>
+          </p:cNvPicPr>
+          <p:nvPr/>
+        </p:nvPicPr>
+        <p:blipFill>
+          <a:blip r:embed="rId1"/>
+          <a:stretch>
+            <a:fillRect/>
+          </a:stretch>
+        </p:blipFill>
+        <p:spPr>
+          <a:xfrm>
+            <a:off x="7594600" y="660400"/>
+            <a:ext cx="3810000" cy="4849091"/>
+          </a:xfrm>
+          <a:prstGeom prst="rect">
+            <a:avLst/>
+          </a:prstGeom>
+        </p:spPr>
+      </p:pic>
+      <p:sp>
+        <p:nvSpPr>
+          <p:cNvPr id="12" name="!!progress"/>
           <p:cNvSpPr/>
           <p:nvPr/>
         </p:nvSpPr>

</xml_diff>